<commit_message>
GEN2-CIERRE-Y-PRODUCTO-3 · frente público regenerado (docs, deck+pptx, one-pager+pdf, README, tablero, catalogo-v1_4.json)
Co-Authored-By: Claude Opus 5.5 <noreply@anthropic.com>
Claude-Session: https://claude.ai/code/session_012iia9fACQCiSAp2WFaALMW
</commit_message>
<xml_diff>
--- a/docs/deck.pptx
+++ b/docs/deck.pptx
@@ -3198,7 +3198,15 @@
               <a:defRPr sz="1600"/>
             </a:pPr>
             <a:r>
-              <a:t>ENDIREH (unidad ASTRA-5 U2) cerrado el 24/sep/2026; INE/ENCUP y el resto de la hoja ASTRA-5 (768 afirmaciones con adquisición identificada) siguen en medición.</a:t>
+              <a:t>Frente prospectivo: las familias 2027 se sellan antes de que INEGI publique la ola; hasta entonces el programa no afirma nada prospectivo sobre ellas.</a:t>
+            </a:r>
+          </a:p>
+          <a:p>
+            <a:pPr>
+              <a:defRPr sz="1600"/>
+            </a:pPr>
+            <a:r>
+              <a:t>Reglas SI-ENTONCES: un bloque de adopción condicional al criterio de CONFIRMA que decide mesa; ninguna regla adoptada todavía.</a:t>
             </a:r>
           </a:p>
           <a:p>
@@ -3372,7 +3380,7 @@
               <a:defRPr sz="1600"/>
             </a:pPr>
             <a:r>
-              <a:t>246 corridas selladas · 66 582 RESULT GEN2 sellados · 72 RESULT GEN2 adoptados activos (el piso que se publica).</a:t>
+              <a:t>318 corridas selladas · 65 480 estimadores en el catálogo v1.4 · 128 RESULT GEN2 adoptados activos por consumidores del motor.</a:t>
             </a:r>
           </a:p>
           <a:p>
@@ -3633,7 +3641,7 @@
               <a:defRPr sz="1600"/>
             </a:pPr>
             <a:r>
-              <a:t>Catálogo v1.0: 1 537 filas de estimando/segmento/ola en 5 áreas de consulta; la mayoría es piso histórico de contexto o propuesta sin adopción.</a:t>
+              <a:t>Catálogo v1.4: 65 480 estimadores con RESULT sellado, en 21 de los 28 dominios del mapa; todos descriptivos, casi todos retrospectivos, cada uno con su firma o el bloque de adopción citado.</a:t>
             </a:r>
           </a:p>
           <a:p>
@@ -3641,7 +3649,7 @@
               <a:defRPr sz="1600"/>
             </a:pPr>
             <a:r>
-              <a:t>72 filas adoptadas (ADOPTADO-POR-FIRMA + CONSUMO-GEN2-ACTIVO) en 4 de 5 áreas: dinero y crédito (27), trámites y Estado (22), tiempo/cuidado y vínculos (13), seguridad y norma (10). Ingreso y gasto está sellado como contexto, sin fila adoptada todavía.</a:t>
+              <a:t>Esta semana: 1 722 filas de 16 CALC entran por bloque (el merge de mesa es la adopción), con reserva de ancho; 22 filas quedan suspendidas por validación ciega o por firma, rotuladas y sin borrar.</a:t>
             </a:r>
           </a:p>
           <a:p>
@@ -3649,7 +3657,7 @@
               <a:defRPr sz="1600"/>
             </a:pPr>
             <a:r>
-              <a:t>ENDIREH e INE/ENCUP siguen en medición; no se presentan como medición publicada.</a:t>
+              <a:t>7 dominios del mapa siguen sin estimador (genética, genómica, humor, interacción, emociones morales, juventud, duelo): «nadie corrió» o «hace falta adquirir», no «no se puede».</a:t>
             </a:r>
           </a:p>
         </p:txBody>
@@ -3957,7 +3965,7 @@
               <a:defRPr sz="1600"/>
             </a:pPr>
             <a:r>
-              <a:t>La tabla de piso publica 72 filas adoptadas — la línea que un retador tiene que vencer, derivada del catálogo por comando, no editada a mano.</a:t>
+              <a:t>La tabla de piso v1.3 publica 65 314 filas — la línea que un retador tiene que vencer, derivada del catálogo por comando, no editada a mano; los contrastes de momento no son línea a vencer.</a:t>
             </a:r>
           </a:p>
           <a:p>

</xml_diff>